<commit_message>
feat:add ppt for rest dotnet
</commit_message>
<xml_diff>
--- a/TI.1.2. PAO202651_SOAP_DOTNET_SINBDD_NRC36884_GR03/05. DOCUMENTACION/PRESENTACION TI.1.2. SOAP sin BDD en DOTNET GR03.pptx
+++ b/TI.1.2. PAO202651_SOAP_DOTNET_SINBDD_NRC36884_GR03/05. DOCUMENTACION/PRESENTACION TI.1.2. SOAP sin BDD en DOTNET GR03.pptx
@@ -322,7 +322,7 @@
   <pc:docChgLst>
     <pc:chgData name="Carlos Hernandez" userId="cb17c3717ba58132" providerId="LiveId" clId="{C654AD1A-6446-42C3-8356-B812B5FDD068}"/>
     <pc:docChg chg="undo custSel delSld modSld">
-      <pc:chgData name="Carlos Hernandez" userId="cb17c3717ba58132" providerId="LiveId" clId="{C654AD1A-6446-42C3-8356-B812B5FDD068}" dt="2026-10-28T13:16:08.267" v="153" actId="1076"/>
+      <pc:chgData name="Carlos Hernandez" userId="cb17c3717ba58132" providerId="LiveId" clId="{C654AD1A-6446-42C3-8356-B812B5FDD068}" dt="2026-10-28T13:56:13.245" v="160" actId="1036"/>
       <pc:docMkLst>
         <pc:docMk/>
       </pc:docMkLst>
@@ -381,7 +381,7 @@
         </pc:picChg>
       </pc:sldChg>
       <pc:sldChg chg="addSp delSp modSp mod">
-        <pc:chgData name="Carlos Hernandez" userId="cb17c3717ba58132" providerId="LiveId" clId="{C654AD1A-6446-42C3-8356-B812B5FDD068}" dt="2026-10-28T13:01:07.616" v="60" actId="1076"/>
+        <pc:chgData name="Carlos Hernandez" userId="cb17c3717ba58132" providerId="LiveId" clId="{C654AD1A-6446-42C3-8356-B812B5FDD068}" dt="2026-10-28T13:50:59.027" v="155" actId="1036"/>
         <pc:sldMkLst>
           <pc:docMk/>
           <pc:sldMk cId="0" sldId="261"/>
@@ -403,7 +403,7 @@
           </ac:spMkLst>
         </pc:spChg>
         <pc:picChg chg="add mod">
-          <ac:chgData name="Carlos Hernandez" userId="cb17c3717ba58132" providerId="LiveId" clId="{C654AD1A-6446-42C3-8356-B812B5FDD068}" dt="2026-10-28T13:01:07.616" v="60" actId="1076"/>
+          <ac:chgData name="Carlos Hernandez" userId="cb17c3717ba58132" providerId="LiveId" clId="{C654AD1A-6446-42C3-8356-B812B5FDD068}" dt="2026-10-28T13:50:59.027" v="155" actId="1036"/>
           <ac:picMkLst>
             <pc:docMk/>
             <pc:sldMk cId="0" sldId="261"/>
@@ -435,7 +435,7 @@
         </pc:picChg>
       </pc:sldChg>
       <pc:sldChg chg="addSp delSp modSp mod">
-        <pc:chgData name="Carlos Hernandez" userId="cb17c3717ba58132" providerId="LiveId" clId="{C654AD1A-6446-42C3-8356-B812B5FDD068}" dt="2026-10-28T13:00:39.616" v="52" actId="1076"/>
+        <pc:chgData name="Carlos Hernandez" userId="cb17c3717ba58132" providerId="LiveId" clId="{C654AD1A-6446-42C3-8356-B812B5FDD068}" dt="2026-10-28T13:50:35.784" v="154" actId="1036"/>
         <pc:sldMkLst>
           <pc:docMk/>
           <pc:sldMk cId="0" sldId="263"/>
@@ -457,7 +457,7 @@
           </ac:spMkLst>
         </pc:spChg>
         <pc:picChg chg="add mod">
-          <ac:chgData name="Carlos Hernandez" userId="cb17c3717ba58132" providerId="LiveId" clId="{C654AD1A-6446-42C3-8356-B812B5FDD068}" dt="2026-10-28T13:00:39.616" v="52" actId="1076"/>
+          <ac:chgData name="Carlos Hernandez" userId="cb17c3717ba58132" providerId="LiveId" clId="{C654AD1A-6446-42C3-8356-B812B5FDD068}" dt="2026-10-28T13:50:35.784" v="154" actId="1036"/>
           <ac:picMkLst>
             <pc:docMk/>
             <pc:sldMk cId="0" sldId="263"/>
@@ -589,7 +589,7 @@
         </pc:picChg>
       </pc:sldChg>
       <pc:sldChg chg="addSp delSp modSp mod">
-        <pc:chgData name="Carlos Hernandez" userId="cb17c3717ba58132" providerId="LiveId" clId="{C654AD1A-6446-42C3-8356-B812B5FDD068}" dt="2026-10-28T13:01:48.133" v="68" actId="1076"/>
+        <pc:chgData name="Carlos Hernandez" userId="cb17c3717ba58132" providerId="LiveId" clId="{C654AD1A-6446-42C3-8356-B812B5FDD068}" dt="2026-10-28T13:51:15.154" v="156" actId="1036"/>
         <pc:sldMkLst>
           <pc:docMk/>
           <pc:sldMk cId="0" sldId="281"/>
@@ -619,7 +619,7 @@
           </ac:picMkLst>
         </pc:picChg>
         <pc:picChg chg="add mod modCrop">
-          <ac:chgData name="Carlos Hernandez" userId="cb17c3717ba58132" providerId="LiveId" clId="{C654AD1A-6446-42C3-8356-B812B5FDD068}" dt="2026-10-28T13:01:48.133" v="68" actId="1076"/>
+          <ac:chgData name="Carlos Hernandez" userId="cb17c3717ba58132" providerId="LiveId" clId="{C654AD1A-6446-42C3-8356-B812B5FDD068}" dt="2026-10-28T13:51:15.154" v="156" actId="1036"/>
           <ac:picMkLst>
             <pc:docMk/>
             <pc:sldMk cId="0" sldId="281"/>
@@ -651,7 +651,7 @@
         </pc:picChg>
       </pc:sldChg>
       <pc:sldChg chg="addSp delSp modSp mod">
-        <pc:chgData name="Carlos Hernandez" userId="cb17c3717ba58132" providerId="LiveId" clId="{C654AD1A-6446-42C3-8356-B812B5FDD068}" dt="2026-10-28T13:03:05.912" v="81" actId="1036"/>
+        <pc:chgData name="Carlos Hernandez" userId="cb17c3717ba58132" providerId="LiveId" clId="{C654AD1A-6446-42C3-8356-B812B5FDD068}" dt="2026-10-28T13:52:49.248" v="157" actId="1036"/>
         <pc:sldMkLst>
           <pc:docMk/>
           <pc:sldMk cId="0" sldId="289"/>
@@ -665,7 +665,7 @@
           </ac:spMkLst>
         </pc:spChg>
         <pc:picChg chg="add mod">
-          <ac:chgData name="Carlos Hernandez" userId="cb17c3717ba58132" providerId="LiveId" clId="{C654AD1A-6446-42C3-8356-B812B5FDD068}" dt="2026-10-28T13:03:05.912" v="81" actId="1036"/>
+          <ac:chgData name="Carlos Hernandez" userId="cb17c3717ba58132" providerId="LiveId" clId="{C654AD1A-6446-42C3-8356-B812B5FDD068}" dt="2026-10-28T13:52:49.248" v="157" actId="1036"/>
           <ac:picMkLst>
             <pc:docMk/>
             <pc:sldMk cId="0" sldId="289"/>
@@ -674,7 +674,7 @@
         </pc:picChg>
       </pc:sldChg>
       <pc:sldChg chg="addSp delSp modSp mod">
-        <pc:chgData name="Carlos Hernandez" userId="cb17c3717ba58132" providerId="LiveId" clId="{C654AD1A-6446-42C3-8356-B812B5FDD068}" dt="2026-10-28T13:04:26.816" v="86" actId="1076"/>
+        <pc:chgData name="Carlos Hernandez" userId="cb17c3717ba58132" providerId="LiveId" clId="{C654AD1A-6446-42C3-8356-B812B5FDD068}" dt="2026-10-28T13:52:58.760" v="158" actId="1036"/>
         <pc:sldMkLst>
           <pc:docMk/>
           <pc:sldMk cId="0" sldId="290"/>
@@ -688,7 +688,7 @@
           </ac:spMkLst>
         </pc:spChg>
         <pc:picChg chg="add mod">
-          <ac:chgData name="Carlos Hernandez" userId="cb17c3717ba58132" providerId="LiveId" clId="{C654AD1A-6446-42C3-8356-B812B5FDD068}" dt="2026-10-28T13:04:26.816" v="86" actId="1076"/>
+          <ac:chgData name="Carlos Hernandez" userId="cb17c3717ba58132" providerId="LiveId" clId="{C654AD1A-6446-42C3-8356-B812B5FDD068}" dt="2026-10-28T13:52:58.760" v="158" actId="1036"/>
           <ac:picMkLst>
             <pc:docMk/>
             <pc:sldMk cId="0" sldId="290"/>
@@ -697,7 +697,7 @@
         </pc:picChg>
       </pc:sldChg>
       <pc:sldChg chg="addSp delSp modSp mod">
-        <pc:chgData name="Carlos Hernandez" userId="cb17c3717ba58132" providerId="LiveId" clId="{C654AD1A-6446-42C3-8356-B812B5FDD068}" dt="2026-10-28T13:04:53.065" v="91" actId="1076"/>
+        <pc:chgData name="Carlos Hernandez" userId="cb17c3717ba58132" providerId="LiveId" clId="{C654AD1A-6446-42C3-8356-B812B5FDD068}" dt="2026-10-28T13:53:19.342" v="159" actId="1036"/>
         <pc:sldMkLst>
           <pc:docMk/>
           <pc:sldMk cId="0" sldId="291"/>
@@ -719,7 +719,7 @@
           </ac:spMkLst>
         </pc:spChg>
         <pc:picChg chg="add mod">
-          <ac:chgData name="Carlos Hernandez" userId="cb17c3717ba58132" providerId="LiveId" clId="{C654AD1A-6446-42C3-8356-B812B5FDD068}" dt="2026-10-28T13:04:53.065" v="91" actId="1076"/>
+          <ac:chgData name="Carlos Hernandez" userId="cb17c3717ba58132" providerId="LiveId" clId="{C654AD1A-6446-42C3-8356-B812B5FDD068}" dt="2026-10-28T13:53:19.342" v="159" actId="1036"/>
           <ac:picMkLst>
             <pc:docMk/>
             <pc:sldMk cId="0" sldId="291"/>
@@ -906,7 +906,7 @@
         </pc:picChg>
       </pc:sldChg>
       <pc:sldChg chg="addSp delSp modSp mod">
-        <pc:chgData name="Carlos Hernandez" userId="cb17c3717ba58132" providerId="LiveId" clId="{C654AD1A-6446-42C3-8356-B812B5FDD068}" dt="2026-10-28T13:10:45.280" v="122" actId="14100"/>
+        <pc:chgData name="Carlos Hernandez" userId="cb17c3717ba58132" providerId="LiveId" clId="{C654AD1A-6446-42C3-8356-B812B5FDD068}" dt="2026-10-28T13:56:13.245" v="160" actId="1036"/>
         <pc:sldMkLst>
           <pc:docMk/>
           <pc:sldMk cId="0" sldId="315"/>
@@ -920,7 +920,7 @@
           </ac:spMkLst>
         </pc:spChg>
         <pc:picChg chg="add mod">
-          <ac:chgData name="Carlos Hernandez" userId="cb17c3717ba58132" providerId="LiveId" clId="{C654AD1A-6446-42C3-8356-B812B5FDD068}" dt="2026-10-28T13:10:45.280" v="122" actId="14100"/>
+          <ac:chgData name="Carlos Hernandez" userId="cb17c3717ba58132" providerId="LiveId" clId="{C654AD1A-6446-42C3-8356-B812B5FDD068}" dt="2026-10-28T13:56:13.245" v="160" actId="1036"/>
           <ac:picMkLst>
             <pc:docMk/>
             <pc:sldMk cId="0" sldId="315"/>
@@ -31625,7 +31625,7 @@
         </p:blipFill>
         <p:spPr>
           <a:xfrm>
-            <a:off x="2932471" y="3196772"/>
+            <a:off x="2932471" y="3205916"/>
             <a:ext cx="3886742" cy="3448531"/>
           </a:xfrm>
           <a:prstGeom prst="rect">
@@ -32176,7 +32176,7 @@
         </p:blipFill>
         <p:spPr>
           <a:xfrm>
-            <a:off x="3415046" y="3246120"/>
+            <a:off x="3415046" y="3255264"/>
             <a:ext cx="2833431" cy="3225602"/>
           </a:xfrm>
           <a:prstGeom prst="rect">
@@ -32936,7 +32936,7 @@
         </p:blipFill>
         <p:spPr>
           <a:xfrm>
-            <a:off x="5249527" y="3936519"/>
+            <a:off x="5249527" y="3945663"/>
             <a:ext cx="3616666" cy="2603500"/>
           </a:xfrm>
           <a:prstGeom prst="rect">
@@ -36344,7 +36344,7 @@
         </p:blipFill>
         <p:spPr>
           <a:xfrm>
-            <a:off x="2924599" y="2427156"/>
+            <a:off x="2924599" y="2436300"/>
             <a:ext cx="5293043" cy="3410627"/>
           </a:xfrm>
           <a:prstGeom prst="rect">
@@ -36931,7 +36931,7 @@
         </p:blipFill>
         <p:spPr>
           <a:xfrm>
-            <a:off x="1122082" y="3784122"/>
+            <a:off x="1122082" y="3793266"/>
             <a:ext cx="8048418" cy="1655826"/>
           </a:xfrm>
           <a:prstGeom prst="rect">
@@ -37527,7 +37527,7 @@
         </p:blipFill>
         <p:spPr>
           <a:xfrm>
-            <a:off x="3190817" y="3261002"/>
+            <a:off x="3190817" y="3270146"/>
             <a:ext cx="2905125" cy="3143250"/>
           </a:xfrm>
           <a:prstGeom prst="rect">
@@ -44384,7 +44384,7 @@
         </p:blipFill>
         <p:spPr>
           <a:xfrm>
-            <a:off x="1082992" y="2476880"/>
+            <a:off x="1082992" y="2486024"/>
             <a:ext cx="7791329" cy="3576447"/>
           </a:xfrm>
           <a:prstGeom prst="rect">

</xml_diff>